<commit_message>
docs: the demo checklist swaps its open defect for the one that actually bites, and the figures follow the code
Section 0 of the morning checklist no longer documents the fixed em-dash column; it documents the
failure that replaces it — a dev server restarted without API_MODE=real serves the mock fixtures and
then 404s every seeded application. Deck and draft re-measured at 314 tests / 5,819 test lines.

DoD: ruff clean (pipeline, eval, builder) · 263+36 pytest passed, 2 skipped · eval.gate PASS ·
11/11 deck pages verified clear of the footer from the PDF's text-box geometry
</commit_message>
<xml_diff>
--- a/docs/submission/sewa-setu.pptx
+++ b/docs/submission/sewa-setu.pptx
@@ -6785,7 +6785,7 @@
                 </a:solidFill>
                 <a:latin typeface="Verdana"/>
               </a:rPr>
-              <a:t>310 automated tests passing, 2 skipped pending a paid model key.</a:t>
+              <a:t>314 automated tests passing, 2 skipped: they need an LLM key in the environment, and the test run has none.</a:t>
             </a:r>
           </a:p>
           <a:p>
@@ -6865,7 +6865,7 @@
                 </a:solidFill>
                 <a:latin typeface="Verdana"/>
               </a:rPr>
-              <a:t>4,080 lines pipeline  ·  1,402 eval harness  ·  3,179 web  ·  1,052 generator  ·  5,794 test lines</a:t>
+              <a:t>4,080 lines pipeline  ·  1,402 eval harness  ·  3,179 web  ·  1,052 generator  ·  5,819 test lines</a:t>
             </a:r>
           </a:p>
         </p:txBody>

</xml_diff>